<commit_message>
restore new pipeline,but edges have some bug,need fix..
</commit_message>
<xml_diff>
--- a/tests/.tmp/filmstrip_p2g_pipeline/filmstrip_output.pptx
+++ b/tests/.tmp/filmstrip_p2g_pipeline/filmstrip_output.pptx
@@ -3096,8 +3096,8 @@
         </p:nvCxnSpPr>
         <p:spPr>
           <a:xfrm>
-            <a:off x="2028825" y="3357562"/>
-            <a:ext cx="552450" cy="0"/>
+            <a:off x="1914525" y="2800350"/>
+            <a:ext cx="514350" cy="0"/>
           </a:xfrm>
           <a:prstGeom prst="line">
             <a:avLst/>
@@ -3131,8 +3131,8 @@
         </p:nvCxnSpPr>
         <p:spPr>
           <a:xfrm>
-            <a:off x="1657350" y="719137"/>
-            <a:ext cx="2867025" cy="2643188"/>
+            <a:off x="3800475" y="2800350"/>
+            <a:ext cx="514350" cy="0"/>
           </a:xfrm>
           <a:prstGeom prst="line">
             <a:avLst/>
@@ -3166,8 +3166,8 @@
         </p:nvCxnSpPr>
         <p:spPr>
           <a:xfrm>
-            <a:off x="3971925" y="3357562"/>
-            <a:ext cx="552450" cy="4763"/>
+            <a:off x="5343525" y="2800350"/>
+            <a:ext cx="514350" cy="0"/>
           </a:xfrm>
           <a:prstGeom prst="line">
             <a:avLst/>
@@ -3201,8 +3201,8 @@
         </p:nvCxnSpPr>
         <p:spPr>
           <a:xfrm>
-            <a:off x="6096000" y="3362325"/>
-            <a:ext cx="552450" cy="0"/>
+            <a:off x="7343775" y="2800350"/>
+            <a:ext cx="609600" cy="0"/>
           </a:xfrm>
           <a:prstGeom prst="line">
             <a:avLst/>
@@ -3236,8 +3236,8 @@
         </p:nvCxnSpPr>
         <p:spPr>
           <a:xfrm flipV="1">
-            <a:off x="7620000" y="2138362"/>
-            <a:ext cx="638175" cy="1223963"/>
+            <a:off x="8982075" y="1943100"/>
+            <a:ext cx="628650" cy="857250"/>
           </a:xfrm>
           <a:prstGeom prst="line">
             <a:avLst/>
@@ -3270,9 +3270,9 @@
           <p:nvPr/>
         </p:nvCxnSpPr>
         <p:spPr>
-          <a:xfrm>
-            <a:off x="9410700" y="2138362"/>
-            <a:ext cx="1095375" cy="4763"/>
+          <a:xfrm flipV="1">
+            <a:off x="10810875" y="1657350"/>
+            <a:ext cx="542925" cy="285750"/>
           </a:xfrm>
           <a:prstGeom prst="line">
             <a:avLst/>
@@ -3305,9 +3305,9 @@
           <p:nvPr/>
         </p:nvCxnSpPr>
         <p:spPr>
-          <a:xfrm>
-            <a:off x="2000250" y="1719262"/>
-            <a:ext cx="8505825" cy="423863"/>
+          <a:xfrm flipV="1">
+            <a:off x="7343775" y="1657350"/>
+            <a:ext cx="523875" cy="1143000"/>
           </a:xfrm>
           <a:prstGeom prst="line">
             <a:avLst/>
@@ -3341,8 +3341,8 @@
         </p:nvCxnSpPr>
         <p:spPr>
           <a:xfrm flipV="1">
-            <a:off x="7620000" y="3357562"/>
-            <a:ext cx="666750" cy="4763"/>
+            <a:off x="9067800" y="1343025"/>
+            <a:ext cx="742950" cy="314325"/>
           </a:xfrm>
           <a:prstGeom prst="line">
             <a:avLst/>
@@ -3376,8 +3376,8 @@
         </p:nvCxnSpPr>
         <p:spPr>
           <a:xfrm>
-            <a:off x="9372600" y="3357562"/>
-            <a:ext cx="685800" cy="0"/>
+            <a:off x="1771650" y="1257300"/>
+            <a:ext cx="8039100" cy="85725"/>
           </a:xfrm>
           <a:prstGeom prst="line">
             <a:avLst/>
@@ -3411,8 +3411,8 @@
         </p:nvCxnSpPr>
         <p:spPr>
           <a:xfrm>
-            <a:off x="7620000" y="3362325"/>
-            <a:ext cx="552450" cy="790575"/>
+            <a:off x="8982075" y="2800350"/>
+            <a:ext cx="600075" cy="0"/>
           </a:xfrm>
           <a:prstGeom prst="line">
             <a:avLst/>
@@ -3446,8 +3446,8 @@
         </p:nvCxnSpPr>
         <p:spPr>
           <a:xfrm>
-            <a:off x="9505950" y="4152900"/>
-            <a:ext cx="2552700" cy="423862"/>
+            <a:off x="10839450" y="2800350"/>
+            <a:ext cx="619125" cy="0"/>
           </a:xfrm>
           <a:prstGeom prst="line">
             <a:avLst/>
@@ -3480,9 +3480,9 @@
           <p:nvPr/>
         </p:nvCxnSpPr>
         <p:spPr>
-          <a:xfrm>
-            <a:off x="11515725" y="3357562"/>
-            <a:ext cx="542925" cy="1219200"/>
+          <a:xfrm flipV="1">
+            <a:off x="12601575" y="2795587"/>
+            <a:ext cx="619125" cy="4763"/>
           </a:xfrm>
           <a:prstGeom prst="line">
             <a:avLst/>
@@ -3515,9 +3515,9 @@
           <p:nvPr/>
         </p:nvCxnSpPr>
         <p:spPr>
-          <a:xfrm flipV="1">
-            <a:off x="9286875" y="4576762"/>
-            <a:ext cx="2771775" cy="347663"/>
+          <a:xfrm>
+            <a:off x="12696825" y="1657350"/>
+            <a:ext cx="523875" cy="1138237"/>
           </a:xfrm>
           <a:prstGeom prst="line">
             <a:avLst/>
@@ -3551,8 +3551,8 @@
         </p:nvCxnSpPr>
         <p:spPr>
           <a:xfrm>
-            <a:off x="7620000" y="3362325"/>
-            <a:ext cx="762000" cy="1562100"/>
+            <a:off x="14535150" y="2795587"/>
+            <a:ext cx="514350" cy="4763"/>
           </a:xfrm>
           <a:prstGeom prst="line">
             <a:avLst/>
@@ -3585,9 +3585,9 @@
           <p:nvPr/>
         </p:nvCxnSpPr>
         <p:spPr>
-          <a:xfrm flipV="1">
-            <a:off x="12844462" y="2628900"/>
-            <a:ext cx="1824038" cy="1676400"/>
+          <a:xfrm>
+            <a:off x="12696825" y="1657350"/>
+            <a:ext cx="4210050" cy="0"/>
           </a:xfrm>
           <a:prstGeom prst="line">
             <a:avLst/>
@@ -3621,8 +3621,8 @@
         </p:nvCxnSpPr>
         <p:spPr>
           <a:xfrm flipV="1">
-            <a:off x="11515725" y="2143125"/>
-            <a:ext cx="4191000" cy="1214437"/>
+            <a:off x="16392525" y="1657350"/>
+            <a:ext cx="514350" cy="1143000"/>
           </a:xfrm>
           <a:prstGeom prst="line">
             <a:avLst/>
@@ -3648,219 +3648,9 @@
           </a:fontRef>
         </p:style>
       </p:cxnSp>
-      <p:cxnSp>
-        <p:nvCxnSpPr>
-          <p:cNvPr id="18" name="Connector 17"/>
-          <p:cNvCxnSpPr/>
-          <p:nvPr/>
-        </p:nvCxnSpPr>
-        <p:spPr>
-          <a:xfrm>
-            <a:off x="15154275" y="2143125"/>
-            <a:ext cx="552450" cy="0"/>
-          </a:xfrm>
-          <a:prstGeom prst="line">
-            <a:avLst/>
-          </a:prstGeom>
-          <a:ln w="19050">
-            <a:solidFill>
-              <a:srgbClr val="808080"/>
-            </a:solidFill>
-          </a:ln>
-        </p:spPr>
-        <p:style>
-          <a:lnRef idx="2">
-            <a:schemeClr val="accent1"/>
-          </a:lnRef>
-          <a:fillRef idx="0">
-            <a:schemeClr val="accent1"/>
-          </a:fillRef>
-          <a:effectRef idx="1">
-            <a:schemeClr val="accent1"/>
-          </a:effectRef>
-          <a:fontRef idx="minor">
-            <a:schemeClr val="tx1"/>
-          </a:fontRef>
-        </p:style>
-      </p:cxnSp>
-      <p:cxnSp>
-        <p:nvCxnSpPr>
-          <p:cNvPr id="19" name="Connector 18"/>
-          <p:cNvCxnSpPr/>
-          <p:nvPr/>
-        </p:nvCxnSpPr>
-        <p:spPr>
-          <a:xfrm>
-            <a:off x="11049000" y="2143125"/>
-            <a:ext cx="5753100" cy="4762"/>
-          </a:xfrm>
-          <a:prstGeom prst="line">
-            <a:avLst/>
-          </a:prstGeom>
-          <a:ln w="19050">
-            <a:solidFill>
-              <a:srgbClr val="808080"/>
-            </a:solidFill>
-          </a:ln>
-        </p:spPr>
-        <p:style>
-          <a:lnRef idx="2">
-            <a:schemeClr val="accent1"/>
-          </a:lnRef>
-          <a:fillRef idx="0">
-            <a:schemeClr val="accent1"/>
-          </a:fillRef>
-          <a:effectRef idx="1">
-            <a:schemeClr val="accent1"/>
-          </a:effectRef>
-          <a:fontRef idx="minor">
-            <a:schemeClr val="tx1"/>
-          </a:fontRef>
-        </p:style>
-      </p:cxnSp>
-      <p:cxnSp>
-        <p:nvCxnSpPr>
-          <p:cNvPr id="20" name="Connector 19"/>
-          <p:cNvCxnSpPr/>
-          <p:nvPr/>
-        </p:nvCxnSpPr>
-        <p:spPr>
-          <a:xfrm>
-            <a:off x="16249650" y="2143125"/>
-            <a:ext cx="552450" cy="4762"/>
-          </a:xfrm>
-          <a:prstGeom prst="line">
-            <a:avLst/>
-          </a:prstGeom>
-          <a:ln w="19050">
-            <a:solidFill>
-              <a:srgbClr val="808080"/>
-            </a:solidFill>
-          </a:ln>
-        </p:spPr>
-        <p:style>
-          <a:lnRef idx="2">
-            <a:schemeClr val="accent1"/>
-          </a:lnRef>
-          <a:fillRef idx="0">
-            <a:schemeClr val="accent1"/>
-          </a:fillRef>
-          <a:effectRef idx="1">
-            <a:schemeClr val="accent1"/>
-          </a:effectRef>
-          <a:fontRef idx="minor">
-            <a:schemeClr val="tx1"/>
-          </a:fontRef>
-        </p:style>
-      </p:cxnSp>
-      <p:cxnSp>
-        <p:nvCxnSpPr>
-          <p:cNvPr id="21" name="Connector 20"/>
-          <p:cNvCxnSpPr/>
-          <p:nvPr/>
-        </p:nvCxnSpPr>
-        <p:spPr>
-          <a:xfrm flipH="1">
-            <a:off x="6096000" y="2147887"/>
-            <a:ext cx="10706100" cy="1214438"/>
-          </a:xfrm>
-          <a:prstGeom prst="line">
-            <a:avLst/>
-          </a:prstGeom>
-          <a:ln w="19050">
-            <a:solidFill>
-              <a:srgbClr val="808080"/>
-            </a:solidFill>
-          </a:ln>
-        </p:spPr>
-        <p:style>
-          <a:lnRef idx="2">
-            <a:schemeClr val="accent1"/>
-          </a:lnRef>
-          <a:fillRef idx="0">
-            <a:schemeClr val="accent1"/>
-          </a:fillRef>
-          <a:effectRef idx="1">
-            <a:schemeClr val="accent1"/>
-          </a:effectRef>
-          <a:fontRef idx="minor">
-            <a:schemeClr val="tx1"/>
-          </a:fontRef>
-        </p:style>
-      </p:cxnSp>
-      <p:cxnSp>
-        <p:nvCxnSpPr>
-          <p:cNvPr id="22" name="Connector 21"/>
-          <p:cNvCxnSpPr/>
-          <p:nvPr/>
-        </p:nvCxnSpPr>
-        <p:spPr>
-          <a:xfrm flipH="1">
-            <a:off x="7620000" y="2147887"/>
-            <a:ext cx="9182100" cy="1214438"/>
-          </a:xfrm>
-          <a:prstGeom prst="line">
-            <a:avLst/>
-          </a:prstGeom>
-          <a:ln w="19050">
-            <a:solidFill>
-              <a:srgbClr val="808080"/>
-            </a:solidFill>
-          </a:ln>
-        </p:spPr>
-        <p:style>
-          <a:lnRef idx="2">
-            <a:schemeClr val="accent1"/>
-          </a:lnRef>
-          <a:fillRef idx="0">
-            <a:schemeClr val="accent1"/>
-          </a:fillRef>
-          <a:effectRef idx="1">
-            <a:schemeClr val="accent1"/>
-          </a:effectRef>
-          <a:fontRef idx="minor">
-            <a:schemeClr val="tx1"/>
-          </a:fontRef>
-        </p:style>
-      </p:cxnSp>
-      <p:cxnSp>
-        <p:nvCxnSpPr>
-          <p:cNvPr id="23" name="Connector 22"/>
-          <p:cNvCxnSpPr/>
-          <p:nvPr/>
-        </p:nvCxnSpPr>
-        <p:spPr>
-          <a:xfrm flipH="1">
-            <a:off x="9372600" y="2147887"/>
-            <a:ext cx="7429500" cy="1209675"/>
-          </a:xfrm>
-          <a:prstGeom prst="line">
-            <a:avLst/>
-          </a:prstGeom>
-          <a:ln w="19050">
-            <a:solidFill>
-              <a:srgbClr val="808080"/>
-            </a:solidFill>
-          </a:ln>
-        </p:spPr>
-        <p:style>
-          <a:lnRef idx="2">
-            <a:schemeClr val="accent1"/>
-          </a:lnRef>
-          <a:fillRef idx="0">
-            <a:schemeClr val="accent1"/>
-          </a:fillRef>
-          <a:effectRef idx="1">
-            <a:schemeClr val="accent1"/>
-          </a:effectRef>
-          <a:fontRef idx="minor">
-            <a:schemeClr val="tx1"/>
-          </a:fontRef>
-        </p:style>
-      </p:cxnSp>
       <p:pic>
         <p:nvPicPr>
-          <p:cNvPr id="24" name="Picture 23" descr="n1.png"/>
+          <p:cNvPr id="18" name="Picture 17" descr="n1.png"/>
           <p:cNvPicPr>
             <a:picLocks noChangeAspect="1"/>
           </p:cNvPicPr>
@@ -3874,8 +3664,8 @@
         </p:blipFill>
         <p:spPr>
           <a:xfrm>
-            <a:off x="571500" y="2632103"/>
-            <a:ext cx="1457325" cy="1450919"/>
+            <a:off x="571500" y="2118597"/>
+            <a:ext cx="1343025" cy="1363506"/>
           </a:xfrm>
           <a:prstGeom prst="rect">
             <a:avLst/>
@@ -3884,7 +3674,7 @@
       </p:pic>
       <p:pic>
         <p:nvPicPr>
-          <p:cNvPr id="25" name="Picture 24" descr="n2.png"/>
+          <p:cNvPr id="19" name="Picture 18" descr="n2.png"/>
           <p:cNvPicPr>
             <a:picLocks noChangeAspect="1"/>
           </p:cNvPicPr>
@@ -3898,8 +3688,8 @@
         </p:blipFill>
         <p:spPr>
           <a:xfrm>
-            <a:off x="581025" y="997294"/>
-            <a:ext cx="1419225" cy="1443937"/>
+            <a:off x="714375" y="574622"/>
+            <a:ext cx="1057275" cy="1365355"/>
           </a:xfrm>
           <a:prstGeom prst="rect">
             <a:avLst/>
@@ -3908,124 +3698,14 @@
       </p:pic>
       <p:sp>
         <p:nvSpPr>
-          <p:cNvPr id="26" name="Rounded Rectangle 25"/>
+          <p:cNvPr id="20" name="Rounded Rectangle 19"/>
           <p:cNvSpPr/>
           <p:nvPr/>
         </p:nvSpPr>
         <p:spPr>
           <a:xfrm>
-            <a:off x="933450" y="571500"/>
-            <a:ext cx="723900" cy="295275"/>
-          </a:xfrm>
-          <a:prstGeom prst="roundRect">
-            <a:avLst/>
-          </a:prstGeom>
-          <a:solidFill>
-            <a:srgbClr val="FC8D62"/>
-          </a:solidFill>
-          <a:ln w="15875">
-            <a:solidFill>
-              <a:srgbClr val="C96B49"/>
-            </a:solidFill>
-          </a:ln>
-        </p:spPr>
-        <p:style>
-          <a:lnRef idx="1">
-            <a:schemeClr val="accent1"/>
-          </a:lnRef>
-          <a:fillRef idx="3">
-            <a:schemeClr val="accent1"/>
-          </a:fillRef>
-          <a:effectRef idx="2">
-            <a:schemeClr val="accent1"/>
-          </a:effectRef>
-          <a:fontRef idx="minor">
-            <a:schemeClr val="lt1"/>
-          </a:fontRef>
-        </p:style>
-        <p:txBody>
-          <a:bodyPr rtlCol="0" anchor="ctr" wrap="square"/>
-          <a:lstStyle/>
-          <a:p>
-            <a:pPr algn="ctr">
-              <a:defRPr sz="1200" b="1" i="0">
-                <a:solidFill>
-                  <a:srgbClr val="333333"/>
-                </a:solidFill>
-                <a:latin typeface="Arial"/>
-              </a:defRPr>
-            </a:pPr>
-            <a:r>
-              <a:t>Loc Token</a:t>
-            </a:r>
-          </a:p>
-        </p:txBody>
-      </p:sp>
-      <p:sp>
-        <p:nvSpPr>
-          <p:cNvPr id="27" name="Rounded Rectangle 26"/>
-          <p:cNvSpPr/>
-          <p:nvPr/>
-        </p:nvSpPr>
-        <p:spPr>
-          <a:xfrm>
-            <a:off x="2581275" y="3114675"/>
-            <a:ext cx="1390650" cy="485775"/>
-          </a:xfrm>
-          <a:prstGeom prst="roundRect">
-            <a:avLst/>
-          </a:prstGeom>
-          <a:solidFill>
-            <a:srgbClr val="4A90D9"/>
-          </a:solidFill>
-          <a:ln w="15875">
-            <a:solidFill>
-              <a:srgbClr val="2E5A8C"/>
-            </a:solidFill>
-          </a:ln>
-        </p:spPr>
-        <p:style>
-          <a:lnRef idx="1">
-            <a:schemeClr val="accent1"/>
-          </a:lnRef>
-          <a:fillRef idx="3">
-            <a:schemeClr val="accent1"/>
-          </a:fillRef>
-          <a:effectRef idx="2">
-            <a:schemeClr val="accent1"/>
-          </a:effectRef>
-          <a:fontRef idx="minor">
-            <a:schemeClr val="lt1"/>
-          </a:fontRef>
-        </p:style>
-        <p:txBody>
-          <a:bodyPr rtlCol="0" anchor="ctr" wrap="square"/>
-          <a:lstStyle/>
-          <a:p>
-            <a:pPr algn="ctr">
-              <a:defRPr sz="1300" b="1" i="0">
-                <a:solidFill>
-                  <a:srgbClr val="FFFFFF"/>
-                </a:solidFill>
-                <a:latin typeface="Arial"/>
-              </a:defRPr>
-            </a:pPr>
-            <a:r>
-              <a:t>Smaller Patch Tokenizer</a:t>
-            </a:r>
-          </a:p>
-        </p:txBody>
-      </p:sp>
-      <p:sp>
-        <p:nvSpPr>
-          <p:cNvPr id="28" name="Rounded Rectangle 27"/>
-          <p:cNvSpPr/>
-          <p:nvPr/>
-        </p:nvSpPr>
-        <p:spPr>
-          <a:xfrm>
-            <a:off x="4524375" y="3028950"/>
-            <a:ext cx="1571625" cy="666750"/>
+            <a:off x="2428875" y="2571750"/>
+            <a:ext cx="1371600" cy="457200"/>
           </a:xfrm>
           <a:prstGeom prst="roundRect">
             <a:avLst/>
@@ -4058,6 +3738,124 @@
           <a:lstStyle/>
           <a:p>
             <a:pPr algn="ctr">
+              <a:defRPr sz="1200" b="1" i="0">
+                <a:solidFill>
+                  <a:srgbClr val="FFFFFF"/>
+                </a:solidFill>
+                <a:latin typeface="Arial"/>
+              </a:defRPr>
+            </a:pPr>
+            <a:r>
+              <a:t>Patch Embedding</a:t>
+            </a:r>
+            <a:br/>
+            <a:r>
+              <a:t>(Small Patches)</a:t>
+            </a:r>
+          </a:p>
+        </p:txBody>
+      </p:sp>
+      <p:sp>
+        <p:nvSpPr>
+          <p:cNvPr id="21" name="Rounded Rectangle 20"/>
+          <p:cNvSpPr/>
+          <p:nvPr/>
+        </p:nvSpPr>
+        <p:spPr>
+          <a:xfrm>
+            <a:off x="4314825" y="2600325"/>
+            <a:ext cx="1028700" cy="400050"/>
+          </a:xfrm>
+          <a:prstGeom prst="roundRect">
+            <a:avLst/>
+          </a:prstGeom>
+          <a:solidFill>
+            <a:srgbClr val="FC8D62"/>
+          </a:solidFill>
+          <a:ln w="19050">
+            <a:solidFill>
+              <a:srgbClr val="C46B4A"/>
+            </a:solidFill>
+          </a:ln>
+        </p:spPr>
+        <p:style>
+          <a:lnRef idx="1">
+            <a:schemeClr val="accent1"/>
+          </a:lnRef>
+          <a:fillRef idx="3">
+            <a:schemeClr val="accent1"/>
+          </a:fillRef>
+          <a:effectRef idx="2">
+            <a:schemeClr val="accent1"/>
+          </a:effectRef>
+          <a:fontRef idx="minor">
+            <a:schemeClr val="lt1"/>
+          </a:fontRef>
+        </p:style>
+        <p:txBody>
+          <a:bodyPr rtlCol="0" anchor="ctr" wrap="square"/>
+          <a:lstStyle/>
+          <a:p>
+            <a:pPr algn="ctr">
+              <a:defRPr sz="1200" b="1" i="0">
+                <a:solidFill>
+                  <a:srgbClr val="FFFFFF"/>
+                </a:solidFill>
+                <a:latin typeface="Arial"/>
+              </a:defRPr>
+            </a:pPr>
+            <a:r>
+              <a:t>Localization</a:t>
+            </a:r>
+            <a:br/>
+            <a:r>
+              <a:t>Token</a:t>
+            </a:r>
+          </a:p>
+        </p:txBody>
+      </p:sp>
+      <p:sp>
+        <p:nvSpPr>
+          <p:cNvPr id="22" name="Rounded Rectangle 21"/>
+          <p:cNvSpPr/>
+          <p:nvPr/>
+        </p:nvSpPr>
+        <p:spPr>
+          <a:xfrm>
+            <a:off x="5857875" y="2486025"/>
+            <a:ext cx="1485900" cy="628650"/>
+          </a:xfrm>
+          <a:prstGeom prst="roundRect">
+            <a:avLst/>
+          </a:prstGeom>
+          <a:solidFill>
+            <a:srgbClr val="4A90D9"/>
+          </a:solidFill>
+          <a:ln w="22225">
+            <a:solidFill>
+              <a:srgbClr val="2E5A8C"/>
+            </a:solidFill>
+          </a:ln>
+        </p:spPr>
+        <p:style>
+          <a:lnRef idx="1">
+            <a:schemeClr val="accent1"/>
+          </a:lnRef>
+          <a:fillRef idx="3">
+            <a:schemeClr val="accent1"/>
+          </a:fillRef>
+          <a:effectRef idx="2">
+            <a:schemeClr val="accent1"/>
+          </a:effectRef>
+          <a:fontRef idx="minor">
+            <a:schemeClr val="lt1"/>
+          </a:fontRef>
+        </p:style>
+        <p:txBody>
+          <a:bodyPr rtlCol="0" anchor="ctr" wrap="square"/>
+          <a:lstStyle/>
+          <a:p>
+            <a:pPr algn="ctr">
               <a:defRPr sz="1400" b="1" i="0">
                 <a:solidFill>
                   <a:srgbClr val="FFFFFF"/>
@@ -4066,21 +3864,84 @@
               </a:defRPr>
             </a:pPr>
             <a:r>
-              <a:t>SegFormer Backbone</a:t>
-            </a:r>
-          </a:p>
-        </p:txBody>
-      </p:sp>
-      <p:sp>
-        <p:nvSpPr>
-          <p:cNvPr id="29" name="Rounded Rectangle 28"/>
+              <a:t>SegFormer</a:t>
+            </a:r>
+            <a:br/>
+            <a:r>
+              <a:t>Backbone</a:t>
+            </a:r>
+          </a:p>
+        </p:txBody>
+      </p:sp>
+      <p:sp>
+        <p:nvSpPr>
+          <p:cNvPr id="23" name="Rounded Rectangle 22"/>
           <p:cNvSpPr/>
           <p:nvPr/>
         </p:nvSpPr>
         <p:spPr>
           <a:xfrm>
-            <a:off x="6648450" y="3152775"/>
-            <a:ext cx="971550" cy="419100"/>
+            <a:off x="7953375" y="2571750"/>
+            <a:ext cx="1028700" cy="457200"/>
+          </a:xfrm>
+          <a:prstGeom prst="roundRect">
+            <a:avLst/>
+          </a:prstGeom>
+          <a:solidFill>
+            <a:srgbClr val="FC8D62"/>
+          </a:solidFill>
+          <a:ln w="19050">
+            <a:solidFill>
+              <a:srgbClr val="C46B4A"/>
+            </a:solidFill>
+          </a:ln>
+        </p:spPr>
+        <p:style>
+          <a:lnRef idx="1">
+            <a:schemeClr val="accent1"/>
+          </a:lnRef>
+          <a:fillRef idx="3">
+            <a:schemeClr val="accent1"/>
+          </a:fillRef>
+          <a:effectRef idx="2">
+            <a:schemeClr val="accent1"/>
+          </a:effectRef>
+          <a:fontRef idx="minor">
+            <a:schemeClr val="lt1"/>
+          </a:fontRef>
+        </p:style>
+        <p:txBody>
+          <a:bodyPr rtlCol="0" anchor="ctr" wrap="square"/>
+          <a:lstStyle/>
+          <a:p>
+            <a:pPr algn="ctr">
+              <a:defRPr sz="1200" b="1" i="0">
+                <a:solidFill>
+                  <a:srgbClr val="FFFFFF"/>
+                </a:solidFill>
+                <a:latin typeface="Arial"/>
+              </a:defRPr>
+            </a:pPr>
+            <a:r>
+              <a:t>Adapter</a:t>
+            </a:r>
+            <a:br/>
+            <a:r>
+              <a:t>Module</a:t>
+            </a:r>
+          </a:p>
+        </p:txBody>
+      </p:sp>
+      <p:sp>
+        <p:nvSpPr>
+          <p:cNvPr id="24" name="Rounded Rectangle 23"/>
+          <p:cNvSpPr/>
+          <p:nvPr/>
+        </p:nvSpPr>
+        <p:spPr>
+          <a:xfrm>
+            <a:off x="7867650" y="1428750"/>
+            <a:ext cx="1200150" cy="457200"/>
           </a:xfrm>
           <a:prstGeom prst="roundRect">
             <a:avLst/>
@@ -4088,9 +3949,9 @@
           <a:solidFill>
             <a:srgbClr val="8DA0CB"/>
           </a:solidFill>
-          <a:ln w="15875">
+          <a:ln w="19050">
             <a:solidFill>
-              <a:srgbClr val="6273A6"/>
+              <a:srgbClr val="5F6F9B"/>
             </a:solidFill>
           </a:ln>
         </p:spPr>
@@ -4113,7 +3974,7 @@
           <a:lstStyle/>
           <a:p>
             <a:pPr algn="ctr">
-              <a:defRPr sz="1300" b="1" i="0">
+              <a:defRPr sz="1200" b="1" i="0">
                 <a:solidFill>
                   <a:srgbClr val="FFFFFF"/>
                 </a:solidFill>
@@ -4121,31 +3982,35 @@
               </a:defRPr>
             </a:pPr>
             <a:r>
-              <a:t>Adapter</a:t>
-            </a:r>
-          </a:p>
-        </p:txBody>
-      </p:sp>
-      <p:sp>
-        <p:nvSpPr>
-          <p:cNvPr id="30" name="Rounded Rectangle 29"/>
+              <a:t>Classification</a:t>
+            </a:r>
+            <a:br/>
+            <a:r>
+              <a:t>Head</a:t>
+            </a:r>
+          </a:p>
+        </p:txBody>
+      </p:sp>
+      <p:sp>
+        <p:nvSpPr>
+          <p:cNvPr id="25" name="Rounded Rectangle 24"/>
           <p:cNvSpPr/>
           <p:nvPr/>
         </p:nvSpPr>
         <p:spPr>
           <a:xfrm>
-            <a:off x="8258175" y="1914525"/>
-            <a:ext cx="1152525" cy="447675"/>
+            <a:off x="9810750" y="1143000"/>
+            <a:ext cx="800100" cy="400050"/>
           </a:xfrm>
           <a:prstGeom prst="roundRect">
             <a:avLst/>
           </a:prstGeom>
           <a:solidFill>
-            <a:srgbClr val="4A90D9"/>
+            <a:srgbClr val="E41A1C"/>
           </a:solidFill>
-          <a:ln w="15875">
+          <a:ln w="19050">
             <a:solidFill>
-              <a:srgbClr val="2E5A8C"/>
+              <a:srgbClr val="A31515"/>
             </a:solidFill>
           </a:ln>
         </p:spPr>
@@ -4168,7 +4033,7 @@
           <a:lstStyle/>
           <a:p>
             <a:pPr algn="ctr">
-              <a:defRPr sz="1300" b="1" i="0">
+              <a:defRPr sz="1200" b="1" i="0">
                 <a:solidFill>
                   <a:srgbClr val="FFFFFF"/>
                 </a:solidFill>
@@ -4176,31 +4041,31 @@
               </a:defRPr>
             </a:pPr>
             <a:r>
-              <a:t>Cls Head</a:t>
-            </a:r>
-          </a:p>
-        </p:txBody>
-      </p:sp>
-      <p:sp>
-        <p:nvSpPr>
-          <p:cNvPr id="31" name="Rounded Rectangle 30"/>
+              <a:t>L_cls</a:t>
+            </a:r>
+          </a:p>
+        </p:txBody>
+      </p:sp>
+      <p:sp>
+        <p:nvSpPr>
+          <p:cNvPr id="26" name="Rounded Rectangle 25"/>
           <p:cNvSpPr/>
           <p:nvPr/>
         </p:nvSpPr>
         <p:spPr>
           <a:xfrm>
-            <a:off x="8286750" y="3114675"/>
-            <a:ext cx="1085850" cy="485775"/>
+            <a:off x="9610725" y="1714500"/>
+            <a:ext cx="1200150" cy="457200"/>
           </a:xfrm>
           <a:prstGeom prst="roundRect">
             <a:avLst/>
           </a:prstGeom>
           <a:solidFill>
-            <a:srgbClr val="4A90D9"/>
+            <a:srgbClr val="66C2A5"/>
           </a:solidFill>
-          <a:ln w="15875">
+          <a:ln w="19050">
             <a:solidFill>
-              <a:srgbClr val="2E5A8C"/>
+              <a:srgbClr val="3A7F73"/>
             </a:solidFill>
           </a:ln>
         </p:spPr>
@@ -4223,7 +4088,7 @@
           <a:lstStyle/>
           <a:p>
             <a:pPr algn="ctr">
-              <a:defRPr sz="1300" b="1" i="0">
+              <a:defRPr sz="1200" b="1" i="0">
                 <a:solidFill>
                   <a:srgbClr val="FFFFFF"/>
                 </a:solidFill>
@@ -4231,6 +4096,10 @@
               </a:defRPr>
             </a:pPr>
             <a:r>
+              <a:t>Segmentation</a:t>
+            </a:r>
+            <a:br/>
+            <a:r>
               <a:t>Decoder</a:t>
             </a:r>
           </a:p>
@@ -4238,24 +4107,24 @@
       </p:sp>
       <p:sp>
         <p:nvSpPr>
-          <p:cNvPr id="32" name="Rounded Rectangle 31"/>
+          <p:cNvPr id="27" name="Rounded Rectangle 26"/>
           <p:cNvSpPr/>
           <p:nvPr/>
         </p:nvSpPr>
         <p:spPr>
           <a:xfrm>
-            <a:off x="8172450" y="3895725"/>
-            <a:ext cx="1333500" cy="514350"/>
+            <a:off x="9582150" y="2571750"/>
+            <a:ext cx="1257300" cy="457200"/>
           </a:xfrm>
           <a:prstGeom prst="roundRect">
             <a:avLst/>
           </a:prstGeom>
           <a:solidFill>
-            <a:srgbClr val="66C2A5"/>
+            <a:srgbClr val="8DA0CB"/>
           </a:solidFill>
-          <a:ln w="15875">
+          <a:ln w="19050">
             <a:solidFill>
-              <a:srgbClr val="3A7F73"/>
+              <a:srgbClr val="5F6F9B"/>
             </a:solidFill>
           </a:ln>
         </p:spPr>
@@ -4278,7 +4147,7 @@
           <a:lstStyle/>
           <a:p>
             <a:pPr algn="ctr">
-              <a:defRPr sz="1300" b="1" i="0">
+              <a:defRPr sz="1200" b="1" i="0">
                 <a:solidFill>
                   <a:srgbClr val="FFFFFF"/>
                 </a:solidFill>
@@ -4286,124 +4155,18 @@
               </a:defRPr>
             </a:pPr>
             <a:r>
-              <a:t>Patch Clustering</a:t>
-            </a:r>
-          </a:p>
-        </p:txBody>
-      </p:sp>
-      <p:sp>
-        <p:nvSpPr>
-          <p:cNvPr id="33" name="Rounded Rectangle 32"/>
-          <p:cNvSpPr/>
-          <p:nvPr/>
-        </p:nvSpPr>
-        <p:spPr>
-          <a:xfrm>
-            <a:off x="8382000" y="4591050"/>
-            <a:ext cx="904875" cy="666750"/>
-          </a:xfrm>
-          <a:prstGeom prst="roundRect">
-            <a:avLst/>
-          </a:prstGeom>
-          <a:solidFill>
-            <a:srgbClr val="EAF2FB"/>
-          </a:solidFill>
-          <a:ln w="15875">
-            <a:solidFill>
-              <a:srgbClr val="2E5A8C"/>
-            </a:solidFill>
-          </a:ln>
-        </p:spPr>
-        <p:style>
-          <a:lnRef idx="1">
-            <a:schemeClr val="accent1"/>
-          </a:lnRef>
-          <a:fillRef idx="3">
-            <a:schemeClr val="accent1"/>
-          </a:fillRef>
-          <a:effectRef idx="2">
-            <a:schemeClr val="accent1"/>
-          </a:effectRef>
-          <a:fontRef idx="minor">
-            <a:schemeClr val="lt1"/>
-          </a:fontRef>
-        </p:style>
-        <p:txBody>
-          <a:bodyPr rtlCol="0" anchor="ctr" wrap="square"/>
-          <a:lstStyle/>
-          <a:p>
-            <a:pPr algn="ctr">
-              <a:defRPr sz="1300" b="1" i="0">
-                <a:solidFill>
-                  <a:srgbClr val="333333"/>
-                </a:solidFill>
-                <a:latin typeface="Arial"/>
-              </a:defRPr>
-            </a:pPr>
-            <a:r>
-              <a:t>Memory Bank</a:t>
-            </a:r>
-          </a:p>
-        </p:txBody>
-      </p:sp>
-      <p:sp>
-        <p:nvSpPr>
-          <p:cNvPr id="34" name="Rounded Rectangle 33"/>
-          <p:cNvSpPr/>
-          <p:nvPr/>
-        </p:nvSpPr>
-        <p:spPr>
-          <a:xfrm>
-            <a:off x="10506075" y="1933575"/>
-            <a:ext cx="542925" cy="419100"/>
-          </a:xfrm>
-          <a:prstGeom prst="roundRect">
-            <a:avLst/>
-          </a:prstGeom>
-          <a:solidFill>
-            <a:srgbClr val="F7F7F7"/>
-          </a:solidFill>
-          <a:ln w="15875">
-            <a:solidFill>
-              <a:srgbClr val="C96B49"/>
-            </a:solidFill>
-          </a:ln>
-        </p:spPr>
-        <p:style>
-          <a:lnRef idx="1">
-            <a:schemeClr val="accent1"/>
-          </a:lnRef>
-          <a:fillRef idx="3">
-            <a:schemeClr val="accent1"/>
-          </a:fillRef>
-          <a:effectRef idx="2">
-            <a:schemeClr val="accent1"/>
-          </a:effectRef>
-          <a:fontRef idx="minor">
-            <a:schemeClr val="lt1"/>
-          </a:fontRef>
-        </p:style>
-        <p:txBody>
-          <a:bodyPr rtlCol="0" anchor="ctr" wrap="square"/>
-          <a:lstStyle/>
-          <a:p>
-            <a:pPr algn="ctr">
-              <a:defRPr sz="1200" b="1" i="0">
-                <a:solidFill>
-                  <a:srgbClr val="333333"/>
-                </a:solidFill>
-                <a:latin typeface="Arial"/>
-              </a:defRPr>
-            </a:pPr>
-            <a:r>
-              <a:t>L_cls</a:t>
+              <a:t>Patch</a:t>
+            </a:r>
+            <a:br/>
+            <a:r>
+              <a:t>Clustering</a:t>
             </a:r>
           </a:p>
         </p:txBody>
       </p:sp>
       <p:pic>
         <p:nvPicPr>
-          <p:cNvPr id="35" name="Picture 34" descr="n10.png"/>
+          <p:cNvPr id="28" name="Picture 27" descr="n10.png"/>
           <p:cNvPicPr>
             <a:picLocks noChangeAspect="1"/>
           </p:cNvPicPr>
@@ -4417,8 +4180,8 @@
         </p:blipFill>
         <p:spPr>
           <a:xfrm>
-            <a:off x="10058400" y="2630505"/>
-            <a:ext cx="1457325" cy="1454115"/>
+            <a:off x="11353800" y="977079"/>
+            <a:ext cx="1343025" cy="1360542"/>
           </a:xfrm>
           <a:prstGeom prst="rect">
             <a:avLst/>
@@ -4427,24 +4190,24 @@
       </p:pic>
       <p:sp>
         <p:nvSpPr>
-          <p:cNvPr id="36" name="Rounded Rectangle 35"/>
+          <p:cNvPr id="29" name="Rounded Rectangle 28"/>
           <p:cNvSpPr/>
           <p:nvPr/>
         </p:nvSpPr>
         <p:spPr>
           <a:xfrm>
-            <a:off x="12058650" y="4305300"/>
-            <a:ext cx="1571625" cy="542925"/>
+            <a:off x="11458575" y="2543175"/>
+            <a:ext cx="1143000" cy="514350"/>
           </a:xfrm>
           <a:prstGeom prst="roundRect">
             <a:avLst/>
           </a:prstGeom>
           <a:solidFill>
-            <a:srgbClr val="4A90D9"/>
+            <a:srgbClr val="FC8D62"/>
           </a:solidFill>
-          <a:ln w="15875">
+          <a:ln w="19050">
             <a:solidFill>
-              <a:srgbClr val="2E5A8C"/>
+              <a:srgbClr val="C46B4A"/>
             </a:solidFill>
           </a:ln>
         </p:spPr>
@@ -4475,14 +4238,77 @@
               </a:defRPr>
             </a:pPr>
             <a:r>
-              <a:t>Pseudo-label Generator</a:t>
+              <a:t>Memory</a:t>
+            </a:r>
+            <a:br/>
+            <a:r>
+              <a:t>Bank</a:t>
+            </a:r>
+          </a:p>
+        </p:txBody>
+      </p:sp>
+      <p:sp>
+        <p:nvSpPr>
+          <p:cNvPr id="30" name="Rounded Rectangle 29"/>
+          <p:cNvSpPr/>
+          <p:nvPr/>
+        </p:nvSpPr>
+        <p:spPr>
+          <a:xfrm>
+            <a:off x="13220700" y="2552700"/>
+            <a:ext cx="1314450" cy="485775"/>
+          </a:xfrm>
+          <a:prstGeom prst="roundRect">
+            <a:avLst/>
+          </a:prstGeom>
+          <a:solidFill>
+            <a:srgbClr val="66C2A5"/>
+          </a:solidFill>
+          <a:ln w="19050">
+            <a:solidFill>
+              <a:srgbClr val="3A7F73"/>
+            </a:solidFill>
+          </a:ln>
+        </p:spPr>
+        <p:style>
+          <a:lnRef idx="1">
+            <a:schemeClr val="accent1"/>
+          </a:lnRef>
+          <a:fillRef idx="3">
+            <a:schemeClr val="accent1"/>
+          </a:fillRef>
+          <a:effectRef idx="2">
+            <a:schemeClr val="accent1"/>
+          </a:effectRef>
+          <a:fontRef idx="minor">
+            <a:schemeClr val="lt1"/>
+          </a:fontRef>
+        </p:style>
+        <p:txBody>
+          <a:bodyPr rtlCol="0" anchor="ctr" wrap="square"/>
+          <a:lstStyle/>
+          <a:p>
+            <a:pPr algn="ctr">
+              <a:defRPr sz="1200" b="1" i="0">
+                <a:solidFill>
+                  <a:srgbClr val="FFFFFF"/>
+                </a:solidFill>
+                <a:latin typeface="Arial"/>
+              </a:defRPr>
+            </a:pPr>
+            <a:r>
+              <a:t>Pseudo-label</a:t>
+            </a:r>
+            <a:br/>
+            <a:r>
+              <a:t>Generator</a:t>
             </a:r>
           </a:p>
         </p:txBody>
       </p:sp>
       <p:pic>
         <p:nvPicPr>
-          <p:cNvPr id="37" name="Picture 36" descr="n14.png"/>
+          <p:cNvPr id="31" name="Picture 30" descr="n14.png"/>
           <p:cNvPicPr>
             <a:picLocks noChangeAspect="1"/>
           </p:cNvPicPr>
@@ -4496,8 +4322,8 @@
         </p:blipFill>
         <p:spPr>
           <a:xfrm>
-            <a:off x="14182725" y="1657350"/>
-            <a:ext cx="971550" cy="971550"/>
+            <a:off x="15049500" y="2118597"/>
+            <a:ext cx="1343025" cy="1363506"/>
           </a:xfrm>
           <a:prstGeom prst="rect">
             <a:avLst/>
@@ -4506,24 +4332,24 @@
       </p:pic>
       <p:sp>
         <p:nvSpPr>
-          <p:cNvPr id="38" name="Rounded Rectangle 37"/>
+          <p:cNvPr id="32" name="Rounded Rectangle 31"/>
           <p:cNvSpPr/>
           <p:nvPr/>
         </p:nvSpPr>
         <p:spPr>
           <a:xfrm>
-            <a:off x="15706725" y="1933575"/>
-            <a:ext cx="542925" cy="419100"/>
+            <a:off x="16906875" y="1457325"/>
+            <a:ext cx="800100" cy="400050"/>
           </a:xfrm>
           <a:prstGeom prst="roundRect">
             <a:avLst/>
           </a:prstGeom>
           <a:solidFill>
-            <a:srgbClr val="F7F7F7"/>
+            <a:srgbClr val="E41A1C"/>
           </a:solidFill>
-          <a:ln w="15875">
+          <a:ln w="19050">
             <a:solidFill>
-              <a:srgbClr val="C96B49"/>
+              <a:srgbClr val="A31515"/>
             </a:solidFill>
           </a:ln>
         </p:spPr>
@@ -4548,68 +4374,13 @@
             <a:pPr algn="ctr">
               <a:defRPr sz="1200" b="1" i="0">
                 <a:solidFill>
-                  <a:srgbClr val="333333"/>
+                  <a:srgbClr val="FFFFFF"/>
                 </a:solidFill>
                 <a:latin typeface="Arial"/>
               </a:defRPr>
             </a:pPr>
             <a:r>
               <a:t>L_ce</a:t>
-            </a:r>
-          </a:p>
-        </p:txBody>
-      </p:sp>
-      <p:sp>
-        <p:nvSpPr>
-          <p:cNvPr id="39" name="Rounded Rectangle 38"/>
-          <p:cNvSpPr/>
-          <p:nvPr/>
-        </p:nvSpPr>
-        <p:spPr>
-          <a:xfrm>
-            <a:off x="16802100" y="1695450"/>
-            <a:ext cx="904875" cy="904875"/>
-          </a:xfrm>
-          <a:prstGeom prst="roundRect">
-            <a:avLst/>
-          </a:prstGeom>
-          <a:solidFill>
-            <a:srgbClr val="FFFFFF"/>
-          </a:solidFill>
-          <a:ln w="15875">
-            <a:solidFill>
-              <a:srgbClr val="666666"/>
-            </a:solidFill>
-          </a:ln>
-        </p:spPr>
-        <p:style>
-          <a:lnRef idx="1">
-            <a:schemeClr val="accent1"/>
-          </a:lnRef>
-          <a:fillRef idx="3">
-            <a:schemeClr val="accent1"/>
-          </a:fillRef>
-          <a:effectRef idx="2">
-            <a:schemeClr val="accent1"/>
-          </a:effectRef>
-          <a:fontRef idx="minor">
-            <a:schemeClr val="lt1"/>
-          </a:fontRef>
-        </p:style>
-        <p:txBody>
-          <a:bodyPr rtlCol="0" anchor="ctr" wrap="square"/>
-          <a:lstStyle/>
-          <a:p>
-            <a:pPr algn="ctr">
-              <a:defRPr sz="1200" b="1" i="0">
-                <a:solidFill>
-                  <a:srgbClr val="333333"/>
-                </a:solidFill>
-                <a:latin typeface="Arial"/>
-              </a:defRPr>
-            </a:pPr>
-            <a:r>
-              <a:t>L = L_cls + L_ce</a:t>
             </a:r>
           </a:p>
         </p:txBody>

</xml_diff>